<commit_message>
docs(presentation): update TerraRisk AI defense presentation slides
</commit_message>
<xml_diff>
--- a/TerraRisk_AI_Presentation.pptx
+++ b/TerraRisk_AI_Presentation.pptx
@@ -1686,7 +1686,7 @@
           <a:p>
             <a:fld id="{5BCAD085-E8A6-8845-BD4E-CB4CCA059FC4}" type="datetimeFigureOut">
               <a:rPr lang="en-US" smtClean="0"/>
-              <a:t>9/7/2026</a:t>
+              <a:t>9/15/2026</a:t>
             </a:fld>
             <a:endParaRPr lang="en-US"/>
           </a:p>
@@ -1854,7 +1854,7 @@
           <a:p>
             <a:fld id="{5BCAD085-E8A6-8845-BD4E-CB4CCA059FC4}" type="datetimeFigureOut">
               <a:rPr lang="en-US" smtClean="0"/>
-              <a:t>9/7/2026</a:t>
+              <a:t>9/15/2026</a:t>
             </a:fld>
             <a:endParaRPr lang="en-US"/>
           </a:p>
@@ -2032,7 +2032,7 @@
           <a:p>
             <a:fld id="{5BCAD085-E8A6-8845-BD4E-CB4CCA059FC4}" type="datetimeFigureOut">
               <a:rPr lang="en-US" smtClean="0"/>
-              <a:t>9/7/2026</a:t>
+              <a:t>9/15/2026</a:t>
             </a:fld>
             <a:endParaRPr lang="en-US"/>
           </a:p>
@@ -2200,7 +2200,7 @@
           <a:p>
             <a:fld id="{5BCAD085-E8A6-8845-BD4E-CB4CCA059FC4}" type="datetimeFigureOut">
               <a:rPr lang="en-US" smtClean="0"/>
-              <a:t>9/7/2026</a:t>
+              <a:t>9/15/2026</a:t>
             </a:fld>
             <a:endParaRPr lang="en-US"/>
           </a:p>
@@ -2445,7 +2445,7 @@
           <a:p>
             <a:fld id="{5BCAD085-E8A6-8845-BD4E-CB4CCA059FC4}" type="datetimeFigureOut">
               <a:rPr lang="en-US" smtClean="0"/>
-              <a:t>9/7/2026</a:t>
+              <a:t>9/15/2026</a:t>
             </a:fld>
             <a:endParaRPr lang="en-US"/>
           </a:p>
@@ -2730,7 +2730,7 @@
           <a:p>
             <a:fld id="{5BCAD085-E8A6-8845-BD4E-CB4CCA059FC4}" type="datetimeFigureOut">
               <a:rPr lang="en-US" smtClean="0"/>
-              <a:t>9/7/2026</a:t>
+              <a:t>9/15/2026</a:t>
             </a:fld>
             <a:endParaRPr lang="en-US"/>
           </a:p>
@@ -3149,7 +3149,7 @@
           <a:p>
             <a:fld id="{5BCAD085-E8A6-8845-BD4E-CB4CCA059FC4}" type="datetimeFigureOut">
               <a:rPr lang="en-US" smtClean="0"/>
-              <a:t>9/7/2026</a:t>
+              <a:t>9/15/2026</a:t>
             </a:fld>
             <a:endParaRPr lang="en-US"/>
           </a:p>
@@ -3266,7 +3266,7 @@
           <a:p>
             <a:fld id="{5BCAD085-E8A6-8845-BD4E-CB4CCA059FC4}" type="datetimeFigureOut">
               <a:rPr lang="en-US" smtClean="0"/>
-              <a:t>9/7/2026</a:t>
+              <a:t>9/15/2026</a:t>
             </a:fld>
             <a:endParaRPr lang="en-US"/>
           </a:p>
@@ -3361,7 +3361,7 @@
           <a:p>
             <a:fld id="{5BCAD085-E8A6-8845-BD4E-CB4CCA059FC4}" type="datetimeFigureOut">
               <a:rPr lang="en-US" smtClean="0"/>
-              <a:t>9/7/2026</a:t>
+              <a:t>9/15/2026</a:t>
             </a:fld>
             <a:endParaRPr lang="en-US"/>
           </a:p>
@@ -3636,7 +3636,7 @@
           <a:p>
             <a:fld id="{5BCAD085-E8A6-8845-BD4E-CB4CCA059FC4}" type="datetimeFigureOut">
               <a:rPr lang="en-US" smtClean="0"/>
-              <a:t>9/7/2026</a:t>
+              <a:t>9/15/2026</a:t>
             </a:fld>
             <a:endParaRPr lang="en-US"/>
           </a:p>
@@ -3888,7 +3888,7 @@
           <a:p>
             <a:fld id="{5BCAD085-E8A6-8845-BD4E-CB4CCA059FC4}" type="datetimeFigureOut">
               <a:rPr lang="en-US" smtClean="0"/>
-              <a:t>9/7/2026</a:t>
+              <a:t>9/15/2026</a:t>
             </a:fld>
             <a:endParaRPr lang="en-US"/>
           </a:p>
@@ -4099,7 +4099,7 @@
           <a:p>
             <a:fld id="{5BCAD085-E8A6-8845-BD4E-CB4CCA059FC4}" type="datetimeFigureOut">
               <a:rPr lang="en-US" smtClean="0"/>
-              <a:t>9/7/2026</a:t>
+              <a:t>9/15/2026</a:t>
             </a:fld>
             <a:endParaRPr lang="en-US"/>
           </a:p>
@@ -4482,7 +4482,7 @@
         </p:nvSpPr>
         <p:spPr>
           <a:xfrm>
-            <a:off x="0" y="0"/>
+            <a:off x="12192" y="0"/>
             <a:ext cx="12191695" cy="6858000"/>
           </a:xfrm>
           <a:prstGeom prst="rect">
@@ -4860,6 +4860,102 @@
             <a:r>
               <a:t>TerraRisk AI</a:t>
             </a:r>
+          </a:p>
+        </p:txBody>
+      </p:sp>
+      <p:sp>
+        <p:nvSpPr>
+          <p:cNvPr id="12" name="Rounded Rectangle 26">
+            <a:extLst>
+              <a:ext uri="{FF2B5EF4-FFF2-40B4-BE49-F238E27FC236}">
+                <a16:creationId xmlns:a16="http://schemas.microsoft.com/office/drawing/2014/main" id="{F1580DD6-40B5-5F88-93F4-DC6AA96669BB}"/>
+              </a:ext>
+            </a:extLst>
+          </p:cNvPr>
+          <p:cNvSpPr/>
+          <p:nvPr/>
+        </p:nvSpPr>
+        <p:spPr>
+          <a:xfrm>
+            <a:off x="7510272" y="4791668"/>
+            <a:ext cx="3767022" cy="923331"/>
+          </a:xfrm>
+          <a:prstGeom prst="roundRect">
+            <a:avLst/>
+          </a:prstGeom>
+          <a:solidFill>
+            <a:srgbClr val="FFFFFF"/>
+          </a:solidFill>
+          <a:ln w="15240">
+            <a:solidFill>
+              <a:srgbClr val="A7F3D0"/>
+            </a:solidFill>
+          </a:ln>
+        </p:spPr>
+        <p:style>
+          <a:lnRef idx="1">
+            <a:schemeClr val="accent1"/>
+          </a:lnRef>
+          <a:fillRef idx="3">
+            <a:schemeClr val="accent1"/>
+          </a:fillRef>
+          <a:effectRef idx="2">
+            <a:schemeClr val="accent1"/>
+          </a:effectRef>
+          <a:fontRef idx="minor">
+            <a:schemeClr val="lt1"/>
+          </a:fontRef>
+        </p:style>
+        <p:txBody>
+          <a:bodyPr rtlCol="0" anchor="ctr"/>
+          <a:lstStyle/>
+          <a:p>
+            <a:pPr algn="ctr"/>
+            <a:endParaRPr/>
+          </a:p>
+        </p:txBody>
+      </p:sp>
+      <p:sp>
+        <p:nvSpPr>
+          <p:cNvPr id="13" name="TextBox 12">
+            <a:extLst>
+              <a:ext uri="{FF2B5EF4-FFF2-40B4-BE49-F238E27FC236}">
+                <a16:creationId xmlns:a16="http://schemas.microsoft.com/office/drawing/2014/main" id="{8A24A6A7-2C02-06C6-AB42-62E0385184E6}"/>
+              </a:ext>
+            </a:extLst>
+          </p:cNvPr>
+          <p:cNvSpPr txBox="1"/>
+          <p:nvPr/>
+        </p:nvSpPr>
+        <p:spPr>
+          <a:xfrm>
+            <a:off x="7735824" y="4897039"/>
+            <a:ext cx="3864864" cy="923330"/>
+          </a:xfrm>
+          <a:prstGeom prst="rect">
+            <a:avLst/>
+          </a:prstGeom>
+          <a:noFill/>
+        </p:spPr>
+        <p:txBody>
+          <a:bodyPr wrap="square" rtlCol="0">
+            <a:spAutoFit/>
+          </a:bodyPr>
+          <a:lstStyle/>
+          <a:p>
+            <a:r>
+              <a:rPr lang="en-IN" dirty="0"/>
+              <a:t>Presented by: Abhinav A R</a:t>
+            </a:r>
+          </a:p>
+          <a:p>
+            <a:r>
+              <a:rPr lang="en-IN" dirty="0"/>
+              <a:t>MSc AI</a:t>
+            </a:r>
+          </a:p>
+          <a:p>
+            <a:endParaRPr lang="en-IN" dirty="0"/>
           </a:p>
         </p:txBody>
       </p:sp>
@@ -6352,7 +6448,7 @@
         <p:spPr>
           <a:xfrm>
             <a:off x="548640" y="347472"/>
-            <a:ext cx="9601200" cy="594360"/>
+            <a:ext cx="9601200" cy="430887"/>
           </a:xfrm>
           <a:prstGeom prst="rect">
             <a:avLst/>
@@ -6373,7 +6469,8 @@
               </a:defRPr>
             </a:pPr>
             <a:r>
-              <a:t>Conclusion: Key Academic &amp; Practical Contributions</a:t>
+              <a:rPr dirty="0"/>
+              <a:t>Conclusion</a:t>
             </a:r>
           </a:p>
         </p:txBody>
@@ -6515,7 +6612,7 @@
         <p:spPr>
           <a:xfrm>
             <a:off x="804672" y="1499616"/>
-            <a:ext cx="4928616" cy="411480"/>
+            <a:ext cx="4928616" cy="269304"/>
           </a:xfrm>
           <a:prstGeom prst="rect">
             <a:avLst/>
@@ -6536,8 +6633,12 @@
               </a:defRPr>
             </a:pPr>
             <a:r>
+              <a:rPr lang="en-IN" dirty="0"/>
+              <a:t>AI </a:t>
+            </a:r>
+            <a:r>
               <a:rPr dirty="0"/>
-              <a:t>Academic &amp; Scientific Contributions</a:t>
+              <a:t>Contributions</a:t>
             </a:r>
           </a:p>
         </p:txBody>
@@ -6633,7 +6734,7 @@
         <p:spPr>
           <a:xfrm>
             <a:off x="763524" y="2240280"/>
-            <a:ext cx="4928616" cy="4480560"/>
+            <a:ext cx="4928616" cy="2887970"/>
           </a:xfrm>
           <a:prstGeom prst="rect">
             <a:avLst/>
@@ -6665,7 +6766,55 @@
                   <a:srgbClr val="334155"/>
                 </a:solidFill>
               </a:rPr>
-              <a:t>Combining slope mechanics with gradient boosting achieved an R² score of 98.54%, far outperforming traditional empirical formulas.</a:t>
+              <a:t>Combining slope mechanics with gradient boosting achieved an R² score of 9</a:t>
+            </a:r>
+            <a:r>
+              <a:rPr lang="en-IN" sz="1450" b="0" dirty="0">
+                <a:solidFill>
+                  <a:srgbClr val="334155"/>
+                </a:solidFill>
+              </a:rPr>
+              <a:t>9</a:t>
+            </a:r>
+            <a:r>
+              <a:rPr sz="1450" b="0" dirty="0">
+                <a:solidFill>
+                  <a:srgbClr val="334155"/>
+                </a:solidFill>
+              </a:rPr>
+              <a:t>.4</a:t>
+            </a:r>
+            <a:r>
+              <a:rPr lang="en-IN" sz="1450" b="0" dirty="0">
+                <a:solidFill>
+                  <a:srgbClr val="334155"/>
+                </a:solidFill>
+              </a:rPr>
+              <a:t>8</a:t>
+            </a:r>
+            <a:r>
+              <a:rPr sz="1450" b="0" dirty="0">
+                <a:solidFill>
+                  <a:srgbClr val="334155"/>
+                </a:solidFill>
+              </a:rPr>
+              <a:t>%, far outperforming traditional</a:t>
+            </a:r>
+            <a:r>
+              <a:rPr lang="en-IN" sz="1450" b="0" dirty="0">
+                <a:solidFill>
+                  <a:srgbClr val="334155"/>
+                </a:solidFill>
+              </a:rPr>
+              <a:t> systems</a:t>
+            </a:r>
+            <a:r>
+              <a:rPr sz="1450" b="0" dirty="0">
+                <a:solidFill>
+                  <a:srgbClr val="334155"/>
+                </a:solidFill>
+              </a:rPr>
+              <a:t>.</a:t>
             </a:r>
           </a:p>
           <a:p>
@@ -12546,7 +12695,7 @@
         <p:spPr>
           <a:xfrm>
             <a:off x="841248" y="2523744"/>
-            <a:ext cx="4928616" cy="4480560"/>
+            <a:ext cx="4928616" cy="3154710"/>
           </a:xfrm>
           <a:prstGeom prst="rect">
             <a:avLst/>
@@ -12639,7 +12788,23 @@
                   <a:srgbClr val="0F172A"/>
                 </a:solidFill>
               </a:rPr>
-              <a:t>• Crowdsourcing Tools (Ushahidi): </a:t>
+              <a:t>• Crowdsourcing Tools</a:t>
+            </a:r>
+            <a:r>
+              <a:rPr lang="en-IN" sz="1400" b="1" dirty="0">
+                <a:solidFill>
+                  <a:srgbClr val="0F172A"/>
+                </a:solidFill>
+              </a:rPr>
+              <a:t> </a:t>
+            </a:r>
+            <a:r>
+              <a:rPr sz="1400" b="1" dirty="0">
+                <a:solidFill>
+                  <a:srgbClr val="0F172A"/>
+                </a:solidFill>
+              </a:rPr>
+              <a:t>: </a:t>
             </a:r>
             <a:r>
               <a:rPr sz="1400" b="0" dirty="0">

</xml_diff>